<commit_message>
Add GitHub and presentation video links, embed demo recording
</commit_message>
<xml_diff>
--- a/iot-server-room-monitor-project.pptx
+++ b/iot-server-room-monitor-project.pptx
@@ -5,7 +5,7 @@
     <p:sldMasterId id="2147483648" r:id="rId1"/>
   </p:sldMasterIdLst>
   <p:notesMasterIdLst>
-    <p:notesMasterId r:id="rId12"/>
+    <p:notesMasterId r:id="rId13"/>
   </p:notesMasterIdLst>
   <p:sldIdLst>
     <p:sldId id="256" r:id="rId2"/>
@@ -18,6 +18,7 @@
     <p:sldId id="264" r:id="rId9"/>
     <p:sldId id="265" r:id="rId10"/>
     <p:sldId id="267" r:id="rId11"/>
+    <p:sldId id="268" r:id="rId12"/>
   </p:sldIdLst>
   <p:sldSz cx="12192000" cy="6858000"/>
   <p:notesSz cx="6858000" cy="9144000"/>
@@ -991,14 +992,16 @@
           <a:lstStyle/>
           <a:p>
             <a:r>
+              <a:rPr dirty="0"/>
               <a:t>This screenshot comes from the repository's current dashboard.py. It shows a controlled demonstration state with a 31.2 degree temperature reading, 78.4 percent humidity, and active A/C, pump, and alarm states. The dashboard itself is the main user interface for this project.</a:t>
             </a:r>
           </a:p>
           <a:p>
-            <a:endParaRPr/>
-          </a:p>
-          <a:p>
-            <a:r>
+            <a:endParaRPr dirty="0"/>
+          </a:p>
+          <a:p>
+            <a:r>
+              <a:rPr dirty="0"/>
               <a:t>Source: https://github.com/aharoni-cohen/iot-smart-home, dashboard.py. Screenshot captured from the repository code in a local offscreen run.</a:t>
             </a:r>
           </a:p>
@@ -1869,9 +1872,27 @@
                 </a:solidFill>
                 <a:latin typeface="Arial"/>
                 <a:cs typeface="Arial"/>
+                <a:hlinkClick r:id="rId3"/>
               </a:rPr>
               <a:t>https://github.com/aharoni-cohen/iot-smart-home</a:t>
             </a:r>
+            <a:r>
+              <a:rPr lang="en-US" sz="1600" dirty="0">
+                <a:solidFill>
+                  <a:srgbClr val="FFFFFF"/>
+                </a:solidFill>
+                <a:latin typeface="Arial"/>
+                <a:cs typeface="Arial"/>
+              </a:rPr>
+              <a:t> - GitHub repository</a:t>
+            </a:r>
+            <a:endParaRPr sz="1600" dirty="0">
+              <a:solidFill>
+                <a:srgbClr val="FFFFFF"/>
+              </a:solidFill>
+              <a:latin typeface="Arial"/>
+              <a:cs typeface="Arial"/>
+            </a:endParaRPr>
           </a:p>
         </p:txBody>
       </p:sp>
@@ -2421,6 +2442,76 @@
               </a:solidFill>
               <a:latin typeface="Arial"/>
               <a:ea typeface="Arial"/>
+              <a:cs typeface="Arial"/>
+            </a:endParaRPr>
+          </a:p>
+        </p:txBody>
+      </p:sp>
+      <p:sp>
+        <p:nvSpPr>
+          <p:cNvPr id="11" name="cover-repo">
+            <a:extLst>
+              <a:ext uri="{FF2B5EF4-FFF2-40B4-BE49-F238E27FC236}">
+                <a16:creationId xmlns:a16="http://schemas.microsoft.com/office/drawing/2014/main" id="{87B69933-9598-A4CC-FC8D-2C946685AF96}"/>
+              </a:ext>
+            </a:extLst>
+          </p:cNvPr>
+          <p:cNvSpPr>
+            <a:spLocks noGrp="1"/>
+          </p:cNvSpPr>
+          <p:nvPr/>
+        </p:nvSpPr>
+        <p:spPr>
+          <a:xfrm>
+            <a:off x="895350" y="5562600"/>
+            <a:ext cx="6457950" cy="304800"/>
+          </a:xfrm>
+          <a:prstGeom prst="rect">
+            <a:avLst/>
+          </a:prstGeom>
+          <a:noFill/>
+          <a:ln w="0">
+            <a:noFill/>
+            <a:prstDash val="solid"/>
+          </a:ln>
+        </p:spPr>
+        <p:txBody>
+          <a:bodyPr wrap="square" lIns="0" tIns="0" rIns="0" bIns="0" anchor="t">
+            <a:normAutofit/>
+          </a:bodyPr>
+          <a:lstStyle/>
+          <a:p>
+            <a:pPr>
+              <a:lnSpc>
+                <a:spcPct val="105000"/>
+              </a:lnSpc>
+            </a:pPr>
+            <a:r>
+              <a:rPr lang="en-US" sz="1600" dirty="0">
+                <a:solidFill>
+                  <a:srgbClr val="FFFFFF"/>
+                </a:solidFill>
+                <a:latin typeface="Arial"/>
+                <a:cs typeface="Arial"/>
+                <a:hlinkClick r:id="rId4"/>
+              </a:rPr>
+              <a:t>https://youtu.be/Q59_BAfpkhk</a:t>
+            </a:r>
+            <a:r>
+              <a:rPr lang="en-US" sz="1600" dirty="0">
+                <a:solidFill>
+                  <a:srgbClr val="FFFFFF"/>
+                </a:solidFill>
+                <a:latin typeface="Arial"/>
+                <a:cs typeface="Arial"/>
+              </a:rPr>
+              <a:t> - presentation video</a:t>
+            </a:r>
+            <a:endParaRPr sz="1600" dirty="0">
+              <a:solidFill>
+                <a:srgbClr val="FFFFFF"/>
+              </a:solidFill>
+              <a:latin typeface="Arial"/>
               <a:cs typeface="Arial"/>
             </a:endParaRPr>
           </a:p>
@@ -3655,6 +3746,209 @@
   <p:clrMapOvr>
     <a:masterClrMapping/>
   </p:clrMapOvr>
+</p:sld>
+</file>
+
+<file path=ppt/slides/slide11.xml><?xml version="1.0" encoding="utf-8"?>
+<p:sld xmlns:a="http://schemas.openxmlformats.org/drawingml/2006/main" xmlns:r="http://schemas.openxmlformats.org/officeDocument/2006/relationships" xmlns:p="http://schemas.openxmlformats.org/presentationml/2006/main">
+  <p:cSld>
+    <p:spTree>
+      <p:nvGrpSpPr>
+        <p:cNvPr id="1" name=""/>
+        <p:cNvGrpSpPr/>
+        <p:nvPr/>
+      </p:nvGrpSpPr>
+      <p:grpSpPr>
+        <a:xfrm>
+          <a:off x="0" y="0"/>
+          <a:ext cx="0" cy="0"/>
+          <a:chOff x="0" y="0"/>
+          <a:chExt cx="0" cy="0"/>
+        </a:xfrm>
+      </p:grpSpPr>
+      <p:pic>
+        <p:nvPicPr>
+          <p:cNvPr id="2" name="video1009572755">
+            <a:hlinkClick r:id="" action="ppaction://media"/>
+            <a:extLst>
+              <a:ext uri="{FF2B5EF4-FFF2-40B4-BE49-F238E27FC236}">
+                <a16:creationId xmlns:a16="http://schemas.microsoft.com/office/drawing/2014/main" id="{1044D69E-39BD-6F13-EA0B-B6CFED11E5DD}"/>
+              </a:ext>
+            </a:extLst>
+          </p:cNvPr>
+          <p:cNvPicPr>
+            <a:picLocks noChangeAspect="1"/>
+          </p:cNvPicPr>
+          <p:nvPr>
+            <a:videoFile r:link="rId2"/>
+            <p:extLst>
+              <p:ext uri="{DAA4B4D4-6D71-4841-9C94-3DE7FCFB9230}">
+                <p14:media xmlns:p14="http://schemas.microsoft.com/office/powerpoint/2010/main" r:embed="rId1"/>
+              </p:ext>
+            </p:extLst>
+          </p:nvPr>
+        </p:nvPicPr>
+        <p:blipFill>
+          <a:blip r:embed="rId4"/>
+          <a:stretch>
+            <a:fillRect/>
+          </a:stretch>
+        </p:blipFill>
+        <p:spPr>
+          <a:xfrm>
+            <a:off x="0" y="0"/>
+            <a:ext cx="17787679" cy="7446274"/>
+          </a:xfrm>
+          <a:prstGeom prst="rect">
+            <a:avLst/>
+          </a:prstGeom>
+        </p:spPr>
+      </p:pic>
+    </p:spTree>
+    <p:extLst>
+      <p:ext uri="{BB962C8B-B14F-4D97-AF65-F5344CB8AC3E}">
+        <p14:creationId xmlns:p14="http://schemas.microsoft.com/office/powerpoint/2010/main" val="3873074513"/>
+      </p:ext>
+    </p:extLst>
+  </p:cSld>
+  <p:clrMapOvr>
+    <a:masterClrMapping/>
+  </p:clrMapOvr>
+  <p:timing>
+    <p:tnLst>
+      <p:par>
+        <p:cTn id="1" dur="indefinite" restart="never" nodeType="tmRoot">
+          <p:childTnLst>
+            <p:seq concurrent="1" nextAc="seek">
+              <p:cTn id="2" dur="indefinite" nodeType="mainSeq">
+                <p:childTnLst>
+                  <p:par>
+                    <p:cTn id="3" fill="hold">
+                      <p:stCondLst>
+                        <p:cond delay="indefinite"/>
+                      </p:stCondLst>
+                      <p:childTnLst>
+                        <p:par>
+                          <p:cTn id="4" fill="hold">
+                            <p:stCondLst>
+                              <p:cond delay="0"/>
+                            </p:stCondLst>
+                            <p:childTnLst>
+                              <p:par>
+                                <p:cTn id="5" presetID="1" presetClass="mediacall" presetSubtype="0" fill="hold" nodeType="clickEffect">
+                                  <p:stCondLst>
+                                    <p:cond delay="0"/>
+                                  </p:stCondLst>
+                                  <p:childTnLst>
+                                    <p:cmd type="call" cmd="playFrom(0.0)">
+                                      <p:cBhvr>
+                                        <p:cTn id="6" dur="52543" fill="hold"/>
+                                        <p:tgtEl>
+                                          <p:spTgt spid="2"/>
+                                        </p:tgtEl>
+                                      </p:cBhvr>
+                                    </p:cmd>
+                                  </p:childTnLst>
+                                </p:cTn>
+                              </p:par>
+                            </p:childTnLst>
+                          </p:cTn>
+                        </p:par>
+                      </p:childTnLst>
+                    </p:cTn>
+                  </p:par>
+                </p:childTnLst>
+              </p:cTn>
+              <p:prevCondLst>
+                <p:cond evt="onPrev" delay="0">
+                  <p:tgtEl>
+                    <p:sldTgt/>
+                  </p:tgtEl>
+                </p:cond>
+              </p:prevCondLst>
+              <p:nextCondLst>
+                <p:cond evt="onNext" delay="0">
+                  <p:tgtEl>
+                    <p:sldTgt/>
+                  </p:tgtEl>
+                </p:cond>
+              </p:nextCondLst>
+            </p:seq>
+            <p:video>
+              <p:cMediaNode vol="80000">
+                <p:cTn id="7" fill="hold" display="0">
+                  <p:stCondLst>
+                    <p:cond delay="indefinite"/>
+                  </p:stCondLst>
+                </p:cTn>
+                <p:tgtEl>
+                  <p:spTgt spid="2"/>
+                </p:tgtEl>
+              </p:cMediaNode>
+            </p:video>
+            <p:seq concurrent="1" nextAc="seek">
+              <p:cTn id="8" restart="whenNotActive" fill="hold" evtFilter="cancelBubble" nodeType="interactiveSeq">
+                <p:stCondLst>
+                  <p:cond evt="onClick" delay="0">
+                    <p:tgtEl>
+                      <p:spTgt spid="2"/>
+                    </p:tgtEl>
+                  </p:cond>
+                </p:stCondLst>
+                <p:endSync evt="end" delay="0">
+                  <p:rtn val="all"/>
+                </p:endSync>
+                <p:childTnLst>
+                  <p:par>
+                    <p:cTn id="9" fill="hold">
+                      <p:stCondLst>
+                        <p:cond delay="0"/>
+                      </p:stCondLst>
+                      <p:childTnLst>
+                        <p:par>
+                          <p:cTn id="10" fill="hold">
+                            <p:stCondLst>
+                              <p:cond delay="0"/>
+                            </p:stCondLst>
+                            <p:childTnLst>
+                              <p:par>
+                                <p:cTn id="11" presetID="2" presetClass="mediacall" presetSubtype="0" fill="hold" nodeType="clickEffect">
+                                  <p:stCondLst>
+                                    <p:cond delay="0"/>
+                                  </p:stCondLst>
+                                  <p:childTnLst>
+                                    <p:cmd type="call" cmd="togglePause">
+                                      <p:cBhvr>
+                                        <p:cTn id="12" dur="1" fill="hold"/>
+                                        <p:tgtEl>
+                                          <p:spTgt spid="2"/>
+                                        </p:tgtEl>
+                                      </p:cBhvr>
+                                    </p:cmd>
+                                  </p:childTnLst>
+                                </p:cTn>
+                              </p:par>
+                            </p:childTnLst>
+                          </p:cTn>
+                        </p:par>
+                      </p:childTnLst>
+                    </p:cTn>
+                  </p:par>
+                </p:childTnLst>
+              </p:cTn>
+              <p:nextCondLst>
+                <p:cond evt="onClick" delay="0">
+                  <p:tgtEl>
+                    <p:spTgt spid="2"/>
+                  </p:tgtEl>
+                </p:cond>
+              </p:nextCondLst>
+            </p:seq>
+          </p:childTnLst>
+        </p:cTn>
+      </p:par>
+    </p:tnLst>
+  </p:timing>
 </p:sld>
 </file>
 

</xml_diff>